<commit_message>
Windows readiness: static checker (HOOK-06), Windows MCP entry, psql/aws lookup on Windows, LF-delimited MCP stdio
- supporting-files/check_windows_readiness.py: twins with BOM/CRLF + launchers, balanced .ps1 syntax,
  references resolve, no drift between hand-written twins and their .sh, generators and Windows agents
  in sync, mcp.json Windows variants, UTF-8 test guards; wired into the hook tests as HOOK-06
- .kiro/settings/mcp.json: sqlmigration-kit-windows (python -X utf8)
- migkit.platform_compat.find_executable: psql.exe / aws.exe under Program Files; used by schema_tool
- kit_mcp_server: UTF-8, LF-delimited messages on every platform
- README, supporting-files README, quick reference, deck, architecture, migration log updated
- Full run on Aurora PostgreSQL 17.7: 694 checks, RESULT: PASS (run 6e888b8a)

Co-Authored-By: Claude Fable 5.1 <noreply@anthropic.com>
</commit_message>
<xml_diff>
--- a/docs/Executive_Overview.pptx
+++ b/docs/Executive_Overview.pptx
@@ -271,7 +271,7 @@
                   <c:v>52</c:v>
                 </c:pt>
                 <c:pt idx="7">
-                  <c:v>30</c:v>
+                  <c:v>31</c:v>
                 </c:pt>
               </c:numCache>
             </c:numRef>
@@ -7952,7 +7952,7 @@
                 <a:ea typeface="Cambria" pitchFamily="34" charset="-122"/>
                 <a:cs typeface="Cambria" pitchFamily="34" charset="-120"/>
               </a:rPr>
-              <a:t>Proof: 693 automated checks, one gate</a:t>
+              <a:t>Proof: 694 automated checks, one gate</a:t>
             </a:r>
             <a:endParaRPr lang="en-US" sz="3200" dirty="0"/>
           </a:p>
@@ -8656,7 +8656,7 @@
                 <a:ea typeface="Calibri" pitchFamily="34" charset="-122"/>
                 <a:cs typeface="Calibri" pitchFamily="34" charset="-120"/>
               </a:rPr>
-              <a:t>12 guardrails · 5 hooks · 8 agent rules · 4 MCP rules</a:t>
+              <a:t>12 guardrails · 6 hooks · 8 agent rules · 4 MCP rules</a:t>
             </a:r>
             <a:endParaRPr lang="en-US" sz="1300" dirty="0"/>
           </a:p>
@@ -13755,7 +13755,7 @@
                 <a:ea typeface="Calibri" pitchFamily="34" charset="-122"/>
                 <a:cs typeface="Calibri" pitchFamily="34" charset="-120"/>
               </a:rPr>
-              <a:t>693 automated checks and a coverage gate on the real target database</a:t>
+              <a:t>694 automated checks and a coverage gate on the real target database</a:t>
             </a:r>
             <a:endParaRPr lang="en-US" sz="2000" dirty="0"/>
           </a:p>

</xml_diff>